<commit_message>
Audita reintentos de mejora condicional PCA v2
</commit_message>
<xml_diff>
--- a/presentaciones/Presentacion-Final-Tesis-PCA-24-10-2026.pptx
+++ b/presentaciones/Presentacion-Final-Tesis-PCA-24-10-2026.pptx
@@ -15,6 +15,7 @@
     <p:sldId id="263" r:id="rId15"/>
     <p:sldId id="264" r:id="rId16"/>
     <p:sldId id="265" r:id="rId17"/>
+    <p:sldId id="266" r:id="rId18"/>
   </p:sldIdLst>
   <p:sldSz cx="16256000" cy="9144000" type="screen4x3"/>
   <p:notesSz cx="6858000" cy="9144000"/>
@@ -12501,6 +12502,887 @@
                 <a:latin typeface="Arial"/>
               </a:rPr>
               <a:t>BA = precisión balanceada; Dummy = 0,3333. Test exploratorio, previamente observado.</a:t>
+            </a:r>
+          </a:p>
+        </p:txBody>
+      </p:sp>
+    </p:spTree>
+  </p:cSld>
+  <p:clrMapOvr>
+    <a:masterClrMapping/>
+  </p:clrMapOvr>
+</p:sld>
+</file>
+
+<file path=ppt/slides/slide11.xml><?xml version="1.0" encoding="utf-8"?>
+<p:sld xmlns:a="http://schemas.openxmlformats.org/drawingml/2006/main" xmlns:p="http://schemas.openxmlformats.org/presentationml/2006/main" xmlns:r="http://schemas.openxmlformats.org/officeDocument/2006/relationships">
+  <p:cSld>
+    <p:bg>
+      <p:bgPr>
+        <a:solidFill>
+          <a:srgbClr val="FFFFFF"/>
+        </a:solidFill>
+        <a:effectLst/>
+      </p:bgPr>
+    </p:bg>
+    <p:spTree>
+      <p:nvGrpSpPr>
+        <p:cNvPr id="1" name=""/>
+        <p:cNvGrpSpPr/>
+        <p:nvPr/>
+      </p:nvGrpSpPr>
+      <p:grpSpPr/>
+      <p:sp>
+        <p:nvSpPr>
+          <p:cNvPr id="2" name="Rounded Rectangle 1"/>
+          <p:cNvSpPr/>
+          <p:nvPr/>
+        </p:nvSpPr>
+        <p:spPr>
+          <a:xfrm>
+            <a:off x="429768" y="393192"/>
+            <a:ext cx="256032" cy="32004"/>
+          </a:xfrm>
+          <a:prstGeom prst="roundRect">
+            <a:avLst/>
+          </a:prstGeom>
+          <a:solidFill>
+            <a:srgbClr val="066A70"/>
+          </a:solidFill>
+          <a:ln w="8890">
+            <a:solidFill>
+              <a:srgbClr val="066A70"/>
+            </a:solidFill>
+          </a:ln>
+        </p:spPr>
+        <p:style>
+          <a:lnRef idx="1">
+            <a:schemeClr val="accent1"/>
+          </a:lnRef>
+          <a:fillRef idx="3">
+            <a:schemeClr val="accent1"/>
+          </a:fillRef>
+          <a:effectRef idx="2">
+            <a:schemeClr val="accent1"/>
+          </a:effectRef>
+          <a:fontRef idx="minor">
+            <a:schemeClr val="lt1"/>
+          </a:fontRef>
+        </p:style>
+        <p:txBody>
+          <a:bodyPr rtlCol="0" anchor="ctr"/>
+          <a:lstStyle/>
+          <a:p>
+            <a:pPr algn="ctr"/>
+          </a:p>
+        </p:txBody>
+      </p:sp>
+      <p:sp>
+        <p:nvSpPr>
+          <p:cNvPr id="3" name="TextBox 2"/>
+          <p:cNvSpPr txBox="1"/>
+          <p:nvPr/>
+        </p:nvSpPr>
+        <p:spPr>
+          <a:xfrm>
+            <a:off x="804672" y="274320"/>
+            <a:ext cx="10149840" cy="274320"/>
+          </a:xfrm>
+          <a:prstGeom prst="rect">
+            <a:avLst/>
+          </a:prstGeom>
+          <a:noFill/>
+        </p:spPr>
+        <p:txBody>
+          <a:bodyPr wrap="square" lIns="27432" rIns="27432" tIns="18288" bIns="18288" anchor="ctr">
+            <a:spAutoFit/>
+          </a:bodyPr>
+          <a:lstStyle/>
+          <a:p>
+            <a:pPr algn="l"/>
+            <a:r>
+              <a:rPr sz="1100" b="0">
+                <a:solidFill>
+                  <a:srgbClr val="4B5968"/>
+                </a:solidFill>
+                <a:latin typeface="Arial"/>
+              </a:rPr>
+              <a:t>Reintentos de predicción · control por estímulo</a:t>
+            </a:r>
+          </a:p>
+        </p:txBody>
+      </p:sp>
+      <p:sp>
+        <p:nvSpPr>
+          <p:cNvPr id="4" name="TextBox 3"/>
+          <p:cNvSpPr txBox="1"/>
+          <p:nvPr/>
+        </p:nvSpPr>
+        <p:spPr>
+          <a:xfrm>
+            <a:off x="438912" y="658368"/>
+            <a:ext cx="11155680" cy="640080"/>
+          </a:xfrm>
+          <a:prstGeom prst="rect">
+            <a:avLst/>
+          </a:prstGeom>
+          <a:noFill/>
+        </p:spPr>
+        <p:txBody>
+          <a:bodyPr wrap="square" lIns="27432" rIns="27432" tIns="18288" bIns="18288" anchor="ctr">
+            <a:spAutoFit/>
+          </a:bodyPr>
+          <a:lstStyle/>
+          <a:p>
+            <a:pPr algn="l"/>
+            <a:r>
+              <a:rPr sz="2900" b="0">
+                <a:solidFill>
+                  <a:srgbClr val="16324F"/>
+                </a:solidFill>
+                <a:latin typeface="Cambria"/>
+              </a:rPr>
+              <a:t>La mejora en validation no se sostuvo en test</a:t>
+            </a:r>
+          </a:p>
+        </p:txBody>
+      </p:sp>
+      <p:sp>
+        <p:nvSpPr>
+          <p:cNvPr id="5" name="Rounded Rectangle 4"/>
+          <p:cNvSpPr/>
+          <p:nvPr/>
+        </p:nvSpPr>
+        <p:spPr>
+          <a:xfrm>
+            <a:off x="438912" y="6473952"/>
+            <a:ext cx="11292840" cy="10972"/>
+          </a:xfrm>
+          <a:prstGeom prst="roundRect">
+            <a:avLst/>
+          </a:prstGeom>
+          <a:solidFill>
+            <a:srgbClr val="CDD7DF"/>
+          </a:solidFill>
+          <a:ln w="8890">
+            <a:solidFill>
+              <a:srgbClr val="CDD7DF"/>
+            </a:solidFill>
+          </a:ln>
+        </p:spPr>
+        <p:style>
+          <a:lnRef idx="1">
+            <a:schemeClr val="accent1"/>
+          </a:lnRef>
+          <a:fillRef idx="3">
+            <a:schemeClr val="accent1"/>
+          </a:fillRef>
+          <a:effectRef idx="2">
+            <a:schemeClr val="accent1"/>
+          </a:effectRef>
+          <a:fontRef idx="minor">
+            <a:schemeClr val="lt1"/>
+          </a:fontRef>
+        </p:style>
+        <p:txBody>
+          <a:bodyPr rtlCol="0" anchor="ctr"/>
+          <a:lstStyle/>
+          <a:p>
+            <a:pPr algn="ctr"/>
+          </a:p>
+        </p:txBody>
+      </p:sp>
+      <p:sp>
+        <p:nvSpPr>
+          <p:cNvPr id="6" name="TextBox 5"/>
+          <p:cNvSpPr txBox="1"/>
+          <p:nvPr/>
+        </p:nvSpPr>
+        <p:spPr>
+          <a:xfrm>
+            <a:off x="448056" y="6510528"/>
+            <a:ext cx="10789920" cy="201168"/>
+          </a:xfrm>
+          <a:prstGeom prst="rect">
+            <a:avLst/>
+          </a:prstGeom>
+          <a:noFill/>
+        </p:spPr>
+        <p:txBody>
+          <a:bodyPr wrap="square" lIns="27432" rIns="27432" tIns="18288" bIns="18288" anchor="ctr">
+            <a:spAutoFit/>
+          </a:bodyPr>
+          <a:lstStyle/>
+          <a:p>
+            <a:pPr algn="l"/>
+            <a:r>
+              <a:rPr sz="900" b="0">
+                <a:solidFill>
+                  <a:srgbClr val="4B5968"/>
+                </a:solidFill>
+                <a:latin typeface="Arial"/>
+              </a:rPr>
+              <a:t>Fuente: Auditoria_PCA_Senales_v2_24-10-2026.md · análisis exploratorio</a:t>
+            </a:r>
+          </a:p>
+        </p:txBody>
+      </p:sp>
+      <p:sp>
+        <p:nvSpPr>
+          <p:cNvPr id="7" name="TextBox 6"/>
+          <p:cNvSpPr txBox="1"/>
+          <p:nvPr/>
+        </p:nvSpPr>
+        <p:spPr>
+          <a:xfrm>
+            <a:off x="11448288" y="6492240"/>
+            <a:ext cx="320040" cy="219456"/>
+          </a:xfrm>
+          <a:prstGeom prst="rect">
+            <a:avLst/>
+          </a:prstGeom>
+          <a:noFill/>
+        </p:spPr>
+        <p:txBody>
+          <a:bodyPr wrap="square" lIns="27432" rIns="27432" tIns="18288" bIns="18288" anchor="ctr">
+            <a:spAutoFit/>
+          </a:bodyPr>
+          <a:lstStyle/>
+          <a:p>
+            <a:pPr algn="r"/>
+            <a:r>
+              <a:rPr sz="1000" b="0">
+                <a:solidFill>
+                  <a:srgbClr val="4B5968"/>
+                </a:solidFill>
+                <a:latin typeface="Arial"/>
+              </a:rPr>
+              <a:t>11</a:t>
+            </a:r>
+          </a:p>
+        </p:txBody>
+      </p:sp>
+      <p:sp>
+        <p:nvSpPr>
+          <p:cNvPr id="8" name="TextBox 7"/>
+          <p:cNvSpPr txBox="1"/>
+          <p:nvPr/>
+        </p:nvSpPr>
+        <p:spPr>
+          <a:xfrm>
+            <a:off x="658368" y="1609344"/>
+            <a:ext cx="1920240" cy="438912"/>
+          </a:xfrm>
+          <a:prstGeom prst="rect">
+            <a:avLst/>
+          </a:prstGeom>
+          <a:noFill/>
+        </p:spPr>
+        <p:txBody>
+          <a:bodyPr wrap="square" lIns="27432" rIns="27432" tIns="18288" bIns="18288" anchor="ctr">
+            <a:spAutoFit/>
+          </a:bodyPr>
+          <a:lstStyle/>
+          <a:p>
+            <a:pPr algn="l"/>
+            <a:r>
+              <a:rPr sz="1600" b="1">
+                <a:solidFill>
+                  <a:srgbClr val="066A70"/>
+                </a:solidFill>
+                <a:latin typeface="Arial"/>
+              </a:rPr>
+              <a:t>Tarea</a:t>
+            </a:r>
+          </a:p>
+        </p:txBody>
+      </p:sp>
+      <p:sp>
+        <p:nvSpPr>
+          <p:cNvPr id="9" name="TextBox 8"/>
+          <p:cNvSpPr txBox="1"/>
+          <p:nvPr/>
+        </p:nvSpPr>
+        <p:spPr>
+          <a:xfrm>
+            <a:off x="2962656" y="1609344"/>
+            <a:ext cx="2011680" cy="438912"/>
+          </a:xfrm>
+          <a:prstGeom prst="rect">
+            <a:avLst/>
+          </a:prstGeom>
+          <a:noFill/>
+        </p:spPr>
+        <p:txBody>
+          <a:bodyPr wrap="square" lIns="27432" rIns="27432" tIns="18288" bIns="18288" anchor="ctr">
+            <a:spAutoFit/>
+          </a:bodyPr>
+          <a:lstStyle/>
+          <a:p>
+            <a:pPr algn="l"/>
+            <a:r>
+              <a:rPr sz="1600" b="1">
+                <a:solidFill>
+                  <a:srgbClr val="066A70"/>
+                </a:solidFill>
+                <a:latin typeface="Arial"/>
+              </a:rPr>
+              <a:t>Solo estímulo</a:t>
+            </a:r>
+          </a:p>
+        </p:txBody>
+      </p:sp>
+      <p:sp>
+        <p:nvSpPr>
+          <p:cNvPr id="10" name="TextBox 9"/>
+          <p:cNvSpPr txBox="1"/>
+          <p:nvPr/>
+        </p:nvSpPr>
+        <p:spPr>
+          <a:xfrm>
+            <a:off x="5687568" y="1609344"/>
+            <a:ext cx="2423160" cy="438912"/>
+          </a:xfrm>
+          <a:prstGeom prst="rect">
+            <a:avLst/>
+          </a:prstGeom>
+          <a:noFill/>
+        </p:spPr>
+        <p:txBody>
+          <a:bodyPr wrap="square" lIns="27432" rIns="27432" tIns="18288" bIns="18288" anchor="ctr">
+            <a:spAutoFit/>
+          </a:bodyPr>
+          <a:lstStyle/>
+          <a:p>
+            <a:pPr algn="l"/>
+            <a:r>
+              <a:rPr sz="1600" b="1">
+                <a:solidFill>
+                  <a:srgbClr val="066A70"/>
+                </a:solidFill>
+                <a:latin typeface="Arial"/>
+              </a:rPr>
+              <a:t>Estímulo + PCA</a:t>
+            </a:r>
+          </a:p>
+        </p:txBody>
+      </p:sp>
+      <p:sp>
+        <p:nvSpPr>
+          <p:cNvPr id="11" name="TextBox 10"/>
+          <p:cNvSpPr txBox="1"/>
+          <p:nvPr/>
+        </p:nvSpPr>
+        <p:spPr>
+          <a:xfrm>
+            <a:off x="9253728" y="1609344"/>
+            <a:ext cx="1463040" cy="438912"/>
+          </a:xfrm>
+          <a:prstGeom prst="rect">
+            <a:avLst/>
+          </a:prstGeom>
+          <a:noFill/>
+        </p:spPr>
+        <p:txBody>
+          <a:bodyPr wrap="square" lIns="27432" rIns="27432" tIns="18288" bIns="18288" anchor="ctr">
+            <a:spAutoFit/>
+          </a:bodyPr>
+          <a:lstStyle/>
+          <a:p>
+            <a:pPr algn="l"/>
+            <a:r>
+              <a:rPr sz="1600" b="1">
+                <a:solidFill>
+                  <a:srgbClr val="066A70"/>
+                </a:solidFill>
+                <a:latin typeface="Arial"/>
+              </a:rPr>
+              <a:t>Cambio</a:t>
+            </a:r>
+          </a:p>
+        </p:txBody>
+      </p:sp>
+      <p:sp>
+        <p:nvSpPr>
+          <p:cNvPr id="12" name="Rounded Rectangle 11"/>
+          <p:cNvSpPr/>
+          <p:nvPr/>
+        </p:nvSpPr>
+        <p:spPr>
+          <a:xfrm>
+            <a:off x="475488" y="2176272"/>
+            <a:ext cx="11201400" cy="758952"/>
+          </a:xfrm>
+          <a:prstGeom prst="roundRect">
+            <a:avLst/>
+          </a:prstGeom>
+          <a:solidFill>
+            <a:srgbClr val="F1F5F8"/>
+          </a:solidFill>
+          <a:ln w="8890">
+            <a:solidFill>
+              <a:srgbClr val="CDD7DF"/>
+            </a:solidFill>
+          </a:ln>
+        </p:spPr>
+        <p:style>
+          <a:lnRef idx="1">
+            <a:schemeClr val="accent1"/>
+          </a:lnRef>
+          <a:fillRef idx="3">
+            <a:schemeClr val="accent1"/>
+          </a:fillRef>
+          <a:effectRef idx="2">
+            <a:schemeClr val="accent1"/>
+          </a:effectRef>
+          <a:fontRef idx="minor">
+            <a:schemeClr val="lt1"/>
+          </a:fontRef>
+        </p:style>
+        <p:txBody>
+          <a:bodyPr rtlCol="0" anchor="ctr"/>
+          <a:lstStyle/>
+          <a:p>
+            <a:pPr algn="ctr"/>
+          </a:p>
+        </p:txBody>
+      </p:sp>
+      <p:sp>
+        <p:nvSpPr>
+          <p:cNvPr id="13" name="TextBox 12"/>
+          <p:cNvSpPr txBox="1"/>
+          <p:nvPr/>
+        </p:nvSpPr>
+        <p:spPr>
+          <a:xfrm>
+            <a:off x="658368" y="2331720"/>
+            <a:ext cx="1920240" cy="429768"/>
+          </a:xfrm>
+          <a:prstGeom prst="rect">
+            <a:avLst/>
+          </a:prstGeom>
+          <a:noFill/>
+        </p:spPr>
+        <p:txBody>
+          <a:bodyPr wrap="square" lIns="27432" rIns="27432" tIns="18288" bIns="18288" anchor="ctr">
+            <a:spAutoFit/>
+          </a:bodyPr>
+          <a:lstStyle/>
+          <a:p>
+            <a:pPr algn="l"/>
+            <a:r>
+              <a:rPr sz="2000" b="1">
+                <a:solidFill>
+                  <a:srgbClr val="16324F"/>
+                </a:solidFill>
+                <a:latin typeface="Arial"/>
+              </a:rPr>
+              <a:t>Atención</a:t>
+            </a:r>
+          </a:p>
+        </p:txBody>
+      </p:sp>
+      <p:sp>
+        <p:nvSpPr>
+          <p:cNvPr id="14" name="TextBox 13"/>
+          <p:cNvSpPr txBox="1"/>
+          <p:nvPr/>
+        </p:nvSpPr>
+        <p:spPr>
+          <a:xfrm>
+            <a:off x="2962656" y="2331720"/>
+            <a:ext cx="2011680" cy="429768"/>
+          </a:xfrm>
+          <a:prstGeom prst="rect">
+            <a:avLst/>
+          </a:prstGeom>
+          <a:noFill/>
+        </p:spPr>
+        <p:txBody>
+          <a:bodyPr wrap="square" lIns="27432" rIns="27432" tIns="18288" bIns="18288" anchor="ctr">
+            <a:spAutoFit/>
+          </a:bodyPr>
+          <a:lstStyle/>
+          <a:p>
+            <a:pPr algn="l"/>
+            <a:r>
+              <a:rPr sz="2000" b="1">
+                <a:solidFill>
+                  <a:srgbClr val="16324F"/>
+                </a:solidFill>
+                <a:latin typeface="Arial"/>
+              </a:rPr>
+              <a:t>0,4613</a:t>
+            </a:r>
+          </a:p>
+        </p:txBody>
+      </p:sp>
+      <p:sp>
+        <p:nvSpPr>
+          <p:cNvPr id="15" name="TextBox 14"/>
+          <p:cNvSpPr txBox="1"/>
+          <p:nvPr/>
+        </p:nvSpPr>
+        <p:spPr>
+          <a:xfrm>
+            <a:off x="5687568" y="2331720"/>
+            <a:ext cx="2423160" cy="429768"/>
+          </a:xfrm>
+          <a:prstGeom prst="rect">
+            <a:avLst/>
+          </a:prstGeom>
+          <a:noFill/>
+        </p:spPr>
+        <p:txBody>
+          <a:bodyPr wrap="square" lIns="27432" rIns="27432" tIns="18288" bIns="18288" anchor="ctr">
+            <a:spAutoFit/>
+          </a:bodyPr>
+          <a:lstStyle/>
+          <a:p>
+            <a:pPr algn="l"/>
+            <a:r>
+              <a:rPr sz="2000" b="1">
+                <a:solidFill>
+                  <a:srgbClr val="16324F"/>
+                </a:solidFill>
+                <a:latin typeface="Arial"/>
+              </a:rPr>
+              <a:t>0,4608</a:t>
+            </a:r>
+          </a:p>
+        </p:txBody>
+      </p:sp>
+      <p:sp>
+        <p:nvSpPr>
+          <p:cNvPr id="16" name="TextBox 15"/>
+          <p:cNvSpPr txBox="1"/>
+          <p:nvPr/>
+        </p:nvSpPr>
+        <p:spPr>
+          <a:xfrm>
+            <a:off x="9253728" y="2331720"/>
+            <a:ext cx="1463040" cy="429768"/>
+          </a:xfrm>
+          <a:prstGeom prst="rect">
+            <a:avLst/>
+          </a:prstGeom>
+          <a:noFill/>
+        </p:spPr>
+        <p:txBody>
+          <a:bodyPr wrap="square" lIns="27432" rIns="27432" tIns="18288" bIns="18288" anchor="ctr">
+            <a:spAutoFit/>
+          </a:bodyPr>
+          <a:lstStyle/>
+          <a:p>
+            <a:pPr algn="l"/>
+            <a:r>
+              <a:rPr sz="2000" b="0">
+                <a:solidFill>
+                  <a:srgbClr val="9A5C15"/>
+                </a:solidFill>
+                <a:latin typeface="Arial"/>
+              </a:rPr>
+              <a:t>−0,0005</a:t>
+            </a:r>
+          </a:p>
+        </p:txBody>
+      </p:sp>
+      <p:sp>
+        <p:nvSpPr>
+          <p:cNvPr id="17" name="Rounded Rectangle 16"/>
+          <p:cNvSpPr/>
+          <p:nvPr/>
+        </p:nvSpPr>
+        <p:spPr>
+          <a:xfrm>
+            <a:off x="475488" y="3136391"/>
+            <a:ext cx="11201400" cy="758952"/>
+          </a:xfrm>
+          <a:prstGeom prst="roundRect">
+            <a:avLst/>
+          </a:prstGeom>
+          <a:solidFill>
+            <a:srgbClr val="F1F5F8"/>
+          </a:solidFill>
+          <a:ln w="8890">
+            <a:solidFill>
+              <a:srgbClr val="CDD7DF"/>
+            </a:solidFill>
+          </a:ln>
+        </p:spPr>
+        <p:style>
+          <a:lnRef idx="1">
+            <a:schemeClr val="accent1"/>
+          </a:lnRef>
+          <a:fillRef idx="3">
+            <a:schemeClr val="accent1"/>
+          </a:fillRef>
+          <a:effectRef idx="2">
+            <a:schemeClr val="accent1"/>
+          </a:effectRef>
+          <a:fontRef idx="minor">
+            <a:schemeClr val="lt1"/>
+          </a:fontRef>
+        </p:style>
+        <p:txBody>
+          <a:bodyPr rtlCol="0" anchor="ctr"/>
+          <a:lstStyle/>
+          <a:p>
+            <a:pPr algn="ctr"/>
+          </a:p>
+        </p:txBody>
+      </p:sp>
+      <p:sp>
+        <p:nvSpPr>
+          <p:cNvPr id="18" name="TextBox 17"/>
+          <p:cNvSpPr txBox="1"/>
+          <p:nvPr/>
+        </p:nvSpPr>
+        <p:spPr>
+          <a:xfrm>
+            <a:off x="658368" y="3291839"/>
+            <a:ext cx="1920240" cy="429768"/>
+          </a:xfrm>
+          <a:prstGeom prst="rect">
+            <a:avLst/>
+          </a:prstGeom>
+          <a:noFill/>
+        </p:spPr>
+        <p:txBody>
+          <a:bodyPr wrap="square" lIns="27432" rIns="27432" tIns="18288" bIns="18288" anchor="ctr">
+            <a:spAutoFit/>
+          </a:bodyPr>
+          <a:lstStyle/>
+          <a:p>
+            <a:pPr algn="l"/>
+            <a:r>
+              <a:rPr sz="2000" b="1">
+                <a:solidFill>
+                  <a:srgbClr val="16324F"/>
+                </a:solidFill>
+                <a:latin typeface="Arial"/>
+              </a:rPr>
+              <a:t>Activación</a:t>
+            </a:r>
+          </a:p>
+        </p:txBody>
+      </p:sp>
+      <p:sp>
+        <p:nvSpPr>
+          <p:cNvPr id="19" name="TextBox 18"/>
+          <p:cNvSpPr txBox="1"/>
+          <p:nvPr/>
+        </p:nvSpPr>
+        <p:spPr>
+          <a:xfrm>
+            <a:off x="2962656" y="3291839"/>
+            <a:ext cx="2011680" cy="429768"/>
+          </a:xfrm>
+          <a:prstGeom prst="rect">
+            <a:avLst/>
+          </a:prstGeom>
+          <a:noFill/>
+        </p:spPr>
+        <p:txBody>
+          <a:bodyPr wrap="square" lIns="27432" rIns="27432" tIns="18288" bIns="18288" anchor="ctr">
+            <a:spAutoFit/>
+          </a:bodyPr>
+          <a:lstStyle/>
+          <a:p>
+            <a:pPr algn="l"/>
+            <a:r>
+              <a:rPr sz="2000" b="1">
+                <a:solidFill>
+                  <a:srgbClr val="16324F"/>
+                </a:solidFill>
+                <a:latin typeface="Arial"/>
+              </a:rPr>
+              <a:t>0,4120</a:t>
+            </a:r>
+          </a:p>
+        </p:txBody>
+      </p:sp>
+      <p:sp>
+        <p:nvSpPr>
+          <p:cNvPr id="20" name="TextBox 19"/>
+          <p:cNvSpPr txBox="1"/>
+          <p:nvPr/>
+        </p:nvSpPr>
+        <p:spPr>
+          <a:xfrm>
+            <a:off x="5687568" y="3291839"/>
+            <a:ext cx="2423160" cy="429768"/>
+          </a:xfrm>
+          <a:prstGeom prst="rect">
+            <a:avLst/>
+          </a:prstGeom>
+          <a:noFill/>
+        </p:spPr>
+        <p:txBody>
+          <a:bodyPr wrap="square" lIns="27432" rIns="27432" tIns="18288" bIns="18288" anchor="ctr">
+            <a:spAutoFit/>
+          </a:bodyPr>
+          <a:lstStyle/>
+          <a:p>
+            <a:pPr algn="l"/>
+            <a:r>
+              <a:rPr sz="2000" b="1">
+                <a:solidFill>
+                  <a:srgbClr val="16324F"/>
+                </a:solidFill>
+                <a:latin typeface="Arial"/>
+              </a:rPr>
+              <a:t>0,3766</a:t>
+            </a:r>
+          </a:p>
+        </p:txBody>
+      </p:sp>
+      <p:sp>
+        <p:nvSpPr>
+          <p:cNvPr id="21" name="TextBox 20"/>
+          <p:cNvSpPr txBox="1"/>
+          <p:nvPr/>
+        </p:nvSpPr>
+        <p:spPr>
+          <a:xfrm>
+            <a:off x="9253728" y="3291839"/>
+            <a:ext cx="1463040" cy="429768"/>
+          </a:xfrm>
+          <a:prstGeom prst="rect">
+            <a:avLst/>
+          </a:prstGeom>
+          <a:noFill/>
+        </p:spPr>
+        <p:txBody>
+          <a:bodyPr wrap="square" lIns="27432" rIns="27432" tIns="18288" bIns="18288" anchor="ctr">
+            <a:spAutoFit/>
+          </a:bodyPr>
+          <a:lstStyle/>
+          <a:p>
+            <a:pPr algn="l"/>
+            <a:r>
+              <a:rPr sz="2000" b="0">
+                <a:solidFill>
+                  <a:srgbClr val="9A5C15"/>
+                </a:solidFill>
+                <a:latin typeface="Arial"/>
+              </a:rPr>
+              <a:t>−0,0353</a:t>
+            </a:r>
+          </a:p>
+        </p:txBody>
+      </p:sp>
+      <p:sp>
+        <p:nvSpPr>
+          <p:cNvPr id="22" name="Rounded Rectangle 21"/>
+          <p:cNvSpPr/>
+          <p:nvPr/>
+        </p:nvSpPr>
+        <p:spPr>
+          <a:xfrm>
+            <a:off x="493776" y="4251960"/>
+            <a:ext cx="11155680" cy="1316736"/>
+          </a:xfrm>
+          <a:prstGeom prst="roundRect">
+            <a:avLst/>
+          </a:prstGeom>
+          <a:solidFill>
+            <a:srgbClr val="FFFFFF"/>
+          </a:solidFill>
+          <a:ln w="8890">
+            <a:solidFill>
+              <a:srgbClr val="066A70"/>
+            </a:solidFill>
+          </a:ln>
+        </p:spPr>
+        <p:style>
+          <a:lnRef idx="1">
+            <a:schemeClr val="accent1"/>
+          </a:lnRef>
+          <a:fillRef idx="3">
+            <a:schemeClr val="accent1"/>
+          </a:fillRef>
+          <a:effectRef idx="2">
+            <a:schemeClr val="accent1"/>
+          </a:effectRef>
+          <a:fontRef idx="minor">
+            <a:schemeClr val="lt1"/>
+          </a:fontRef>
+        </p:style>
+        <p:txBody>
+          <a:bodyPr rtlCol="0" anchor="ctr"/>
+          <a:lstStyle/>
+          <a:p>
+            <a:pPr algn="ctr"/>
+          </a:p>
+        </p:txBody>
+      </p:sp>
+      <p:sp>
+        <p:nvSpPr>
+          <p:cNvPr id="23" name="TextBox 22"/>
+          <p:cNvSpPr txBox="1"/>
+          <p:nvPr/>
+        </p:nvSpPr>
+        <p:spPr>
+          <a:xfrm>
+            <a:off x="731520" y="4370832"/>
+            <a:ext cx="10652760" cy="1042415"/>
+          </a:xfrm>
+          <a:prstGeom prst="rect">
+            <a:avLst/>
+          </a:prstGeom>
+          <a:noFill/>
+        </p:spPr>
+        <p:txBody>
+          <a:bodyPr wrap="square" lIns="27432" rIns="27432" tIns="18288" bIns="18288" anchor="ctr">
+            <a:spAutoFit/>
+          </a:bodyPr>
+          <a:lstStyle/>
+          <a:p>
+            <a:pPr algn="l"/>
+            <a:r>
+              <a:rPr sz="1800" b="1">
+                <a:solidFill>
+                  <a:srgbClr val="16324F"/>
+                </a:solidFill>
+                <a:latin typeface="Arial"/>
+              </a:rPr>
+              <a:t>En validation, el PCA parecía sumar: atención 0,4728 frente a 0,4659; activación 0,4325 frente a 0,4082. El resultado no se generalizó.</a:t>
+            </a:r>
+          </a:p>
+        </p:txBody>
+      </p:sp>
+      <p:sp>
+        <p:nvSpPr>
+          <p:cNvPr id="24" name="TextBox 23"/>
+          <p:cNvSpPr txBox="1"/>
+          <p:nvPr/>
+        </p:nvSpPr>
+        <p:spPr>
+          <a:xfrm>
+            <a:off x="512064" y="5806440"/>
+            <a:ext cx="11064240" cy="512064"/>
+          </a:xfrm>
+          <a:prstGeom prst="rect">
+            <a:avLst/>
+          </a:prstGeom>
+          <a:noFill/>
+        </p:spPr>
+        <p:txBody>
+          <a:bodyPr wrap="square" lIns="27432" rIns="27432" tIns="18288" bIns="18288" anchor="ctr">
+            <a:spAutoFit/>
+          </a:bodyPr>
+          <a:lstStyle/>
+          <a:p>
+            <a:pPr algn="l"/>
+            <a:r>
+              <a:rPr sz="1300" b="0">
+                <a:solidFill>
+                  <a:srgbClr val="9A5C15"/>
+                </a:solidFill>
+                <a:latin typeface="Arial"/>
+              </a:rPr>
+              <a:t>Un PC/señal dio 0,4658 en atención, pero 0,4722 con las señales desordenadas. Test exploratorio ya consultado.</a:t>
             </a:r>
           </a:p>
         </p:txBody>

</xml_diff>